<commit_message>
chore(slides): trocar fontes pra Arial/Courier New (compatibilidade Google Slides)
</commit_message>
<xml_diff>
--- a/slides/apresentacao.pptx
+++ b/slides/apresentacao.pptx
@@ -3172,7 +3172,7 @@
                 <a:solidFill>
                   <a:srgbClr val="E4E4E7"/>
                 </a:solidFill>
-                <a:latin typeface="Calibri"/>
+                <a:latin typeface="Arial"/>
               </a:rPr>
               <a:t>🧮</a:t>
             </a:r>
@@ -3207,7 +3207,7 @@
                 <a:solidFill>
                   <a:srgbClr val="FFFFFF"/>
                 </a:solidFill>
-                <a:latin typeface="Calibri"/>
+                <a:latin typeface="Arial"/>
               </a:rPr>
               <a:t>Versionamento de Código com Git</a:t>
             </a:r>
@@ -3242,7 +3242,7 @@
                 <a:solidFill>
                   <a:srgbClr val="F9A026"/>
                 </a:solidFill>
-                <a:latin typeface="Calibri"/>
+                <a:latin typeface="Arial"/>
               </a:rPr>
               <a:t>Um bug, uma branch, uma correção.</a:t>
             </a:r>
@@ -3277,7 +3277,7 @@
                 <a:solidFill>
                   <a:srgbClr val="E4E4E7"/>
                 </a:solidFill>
-                <a:latin typeface="Calibri"/>
+                <a:latin typeface="Arial"/>
               </a:rPr>
               <a:t>Demo prática: calculadora em Python</a:t>
             </a:r>
@@ -3460,7 +3460,7 @@
                 <a:solidFill>
                   <a:srgbClr val="FFFFFF"/>
                 </a:solidFill>
-                <a:latin typeface="Calibri"/>
+                <a:latin typeface="Arial"/>
               </a:rPr>
               <a:t>Passo 4 — Corrigir o caminho do logo</a:t>
             </a:r>
@@ -3495,7 +3495,7 @@
                 <a:solidFill>
                   <a:srgbClr val="F9A026"/>
                 </a:solidFill>
-                <a:latin typeface="Calibri"/>
+                <a:latin typeface="Arial"/>
               </a:rPr>
               <a:t>Arquivo: src/App.jsx</a:t>
             </a:r>
@@ -3530,7 +3530,7 @@
                 <a:solidFill>
                   <a:srgbClr val="888899"/>
                 </a:solidFill>
-                <a:latin typeface="Calibri"/>
+                <a:latin typeface="Arial"/>
               </a:rPr>
               <a:t>Versionamento com Git  •  Slide 10/13</a:t>
             </a:r>
@@ -3565,7 +3565,7 @@
                 <a:solidFill>
                   <a:srgbClr val="EF4444"/>
                 </a:solidFill>
-                <a:latin typeface="Calibri"/>
+                <a:latin typeface="Arial"/>
               </a:rPr>
               <a:t>ANTES (com bug):</a:t>
             </a:r>
@@ -3646,7 +3646,7 @@
                 <a:solidFill>
                   <a:srgbClr val="EF4444"/>
                 </a:solidFill>
-                <a:latin typeface="Consolas"/>
+                <a:latin typeface="Courier New"/>
               </a:rPr>
               <a:t>&lt;img src="/logoo.svg"</a:t>
             </a:r>
@@ -3657,7 +3657,7 @@
                 <a:solidFill>
                   <a:srgbClr val="10D990"/>
                 </a:solidFill>
-                <a:latin typeface="Consolas"/>
+                <a:latin typeface="Courier New"/>
               </a:rPr>
               <a:t>     alt="Git Demo" /&gt;</a:t>
             </a:r>
@@ -3692,7 +3692,7 @@
                 <a:solidFill>
                   <a:srgbClr val="10D990"/>
                 </a:solidFill>
-                <a:latin typeface="Calibri"/>
+                <a:latin typeface="Arial"/>
               </a:rPr>
               <a:t>DEPOIS (corrigido):</a:t>
             </a:r>
@@ -3773,7 +3773,7 @@
                 <a:solidFill>
                   <a:srgbClr val="10D990"/>
                 </a:solidFill>
-                <a:latin typeface="Consolas"/>
+                <a:latin typeface="Courier New"/>
               </a:rPr>
               <a:t>&lt;img src="/logo.svg"</a:t>
             </a:r>
@@ -3784,7 +3784,7 @@
                 <a:solidFill>
                   <a:srgbClr val="10D990"/>
                 </a:solidFill>
-                <a:latin typeface="Consolas"/>
+                <a:latin typeface="Courier New"/>
               </a:rPr>
               <a:t>     alt="Git Demo" /&gt;</a:t>
             </a:r>
@@ -3819,7 +3819,7 @@
                 <a:solidFill>
                   <a:srgbClr val="F9A026"/>
                 </a:solidFill>
-                <a:latin typeface="Calibri"/>
+                <a:latin typeface="Arial"/>
               </a:rPr>
               <a:t>Removeu UM caractere.  Salve e dê refresh no navegador:</a:t>
             </a:r>
@@ -3900,7 +3900,7 @@
                 <a:solidFill>
                   <a:srgbClr val="10D990"/>
                 </a:solidFill>
-                <a:latin typeface="Consolas"/>
+                <a:latin typeface="Courier New"/>
               </a:rPr>
               <a:t>GET   /logo.svg     200 OK  ✅   (e o logo aparece!)</a:t>
             </a:r>
@@ -4040,7 +4040,7 @@
                 <a:solidFill>
                   <a:srgbClr val="FFFFFF"/>
                 </a:solidFill>
-                <a:latin typeface="Calibri"/>
+                <a:latin typeface="Arial"/>
               </a:rPr>
               <a:t>Passo 5 — Registrar a correção (commit)</a:t>
             </a:r>
@@ -4075,7 +4075,7 @@
                 <a:solidFill>
                   <a:srgbClr val="888899"/>
                 </a:solidFill>
-                <a:latin typeface="Calibri"/>
+                <a:latin typeface="Arial"/>
               </a:rPr>
               <a:t>Versionamento com Git  •  Slide 11/13</a:t>
             </a:r>
@@ -4156,7 +4156,7 @@
                 <a:solidFill>
                   <a:srgbClr val="10D990"/>
                 </a:solidFill>
-                <a:latin typeface="Consolas"/>
+                <a:latin typeface="Courier New"/>
               </a:rPr>
               <a:t>git status</a:t>
             </a:r>
@@ -4167,7 +4167,7 @@
                 <a:solidFill>
                   <a:srgbClr val="10D990"/>
                 </a:solidFill>
-                <a:latin typeface="Consolas"/>
+                <a:latin typeface="Courier New"/>
               </a:rPr>
               <a:t>git add src/App.jsx</a:t>
             </a:r>
@@ -4178,7 +4178,7 @@
                 <a:solidFill>
                   <a:srgbClr val="10D990"/>
                 </a:solidFill>
-                <a:latin typeface="Consolas"/>
+                <a:latin typeface="Courier New"/>
               </a:rPr>
               <a:t>git commit -m "fix: corrige caminho do logo que retornava 404"</a:t>
             </a:r>
@@ -4213,7 +4213,7 @@
                 <a:solidFill>
                   <a:srgbClr val="F9A026"/>
                 </a:solidFill>
-                <a:latin typeface="Calibri"/>
+                <a:latin typeface="Arial"/>
               </a:rPr>
               <a:t>Dica de mensagem de commit:</a:t>
             </a:r>
@@ -4252,7 +4252,7 @@
                 <a:solidFill>
                   <a:srgbClr val="E4E4E7"/>
                 </a:solidFill>
-                <a:latin typeface="Calibri"/>
+                <a:latin typeface="Arial"/>
               </a:rPr>
               <a:t>•  fix: corrige bug que estava quebrando X</a:t>
             </a:r>
@@ -4268,7 +4268,7 @@
                 <a:solidFill>
                   <a:srgbClr val="E4E4E7"/>
                 </a:solidFill>
-                <a:latin typeface="Calibri"/>
+                <a:latin typeface="Arial"/>
               </a:rPr>
               <a:t>•  feat: adiciona funcionalidade Y</a:t>
             </a:r>
@@ -4284,7 +4284,7 @@
                 <a:solidFill>
                   <a:srgbClr val="E4E4E7"/>
                 </a:solidFill>
-                <a:latin typeface="Calibri"/>
+                <a:latin typeface="Arial"/>
               </a:rPr>
               <a:t>•  docs: atualiza README</a:t>
             </a:r>
@@ -4300,7 +4300,7 @@
                 <a:solidFill>
                   <a:srgbClr val="E4E4E7"/>
                 </a:solidFill>
-                <a:latin typeface="Calibri"/>
+                <a:latin typeface="Arial"/>
               </a:rPr>
               <a:t>•  refactor: reorganiza estrutura do arquivo Z</a:t>
             </a:r>
@@ -4440,7 +4440,7 @@
                 <a:solidFill>
                   <a:srgbClr val="FFFFFF"/>
                 </a:solidFill>
-                <a:latin typeface="Calibri"/>
+                <a:latin typeface="Arial"/>
               </a:rPr>
               <a:t>Passo 6 — Push + Pull Request</a:t>
             </a:r>
@@ -4475,7 +4475,7 @@
                 <a:solidFill>
                   <a:srgbClr val="888899"/>
                 </a:solidFill>
-                <a:latin typeface="Calibri"/>
+                <a:latin typeface="Arial"/>
               </a:rPr>
               <a:t>Versionamento com Git  •  Slide 12/13</a:t>
             </a:r>
@@ -4556,7 +4556,7 @@
                 <a:solidFill>
                   <a:srgbClr val="10D990"/>
                 </a:solidFill>
-                <a:latin typeface="Consolas"/>
+                <a:latin typeface="Courier New"/>
               </a:rPr>
               <a:t>git push origin fix/logo-path</a:t>
             </a:r>
@@ -4591,7 +4591,7 @@
                 <a:solidFill>
                   <a:srgbClr val="F9A026"/>
                 </a:solidFill>
-                <a:latin typeface="Calibri"/>
+                <a:latin typeface="Arial"/>
               </a:rPr>
               <a:t>Depois, no GitHub:</a:t>
             </a:r>
@@ -4630,7 +4630,7 @@
                 <a:solidFill>
                   <a:srgbClr val="E4E4E7"/>
                 </a:solidFill>
-                <a:latin typeface="Calibri"/>
+                <a:latin typeface="Arial"/>
               </a:rPr>
               <a:t>•  Aparecerá o botão 'Compare &amp; pull request' — clique nele</a:t>
             </a:r>
@@ -4646,7 +4646,7 @@
                 <a:solidFill>
                   <a:srgbClr val="E4E4E7"/>
                 </a:solidFill>
-                <a:latin typeface="Calibri"/>
+                <a:latin typeface="Arial"/>
               </a:rPr>
               <a:t>•  Escreva um título claro e descreva o que você corrigiu</a:t>
             </a:r>
@@ -4662,7 +4662,7 @@
                 <a:solidFill>
                   <a:srgbClr val="E4E4E7"/>
                 </a:solidFill>
-                <a:latin typeface="Calibri"/>
+                <a:latin typeface="Arial"/>
               </a:rPr>
               <a:t>•  Clique em 'Create pull request'</a:t>
             </a:r>
@@ -4678,7 +4678,7 @@
                 <a:solidFill>
                   <a:srgbClr val="E4E4E7"/>
                 </a:solidFill>
-                <a:latin typeface="Calibri"/>
+                <a:latin typeface="Arial"/>
               </a:rPr>
               <a:t>•  Peça pro colega revisar — é assim que funciona no mundo real</a:t>
             </a:r>
@@ -4694,7 +4694,7 @@
                 <a:solidFill>
                   <a:srgbClr val="E4E4E7"/>
                 </a:solidFill>
-                <a:latin typeface="Calibri"/>
+                <a:latin typeface="Arial"/>
               </a:rPr>
               <a:t>•  Após aprovação: 'Merge pull request' leva a correção pra main 🎉</a:t>
             </a:r>
@@ -4877,7 +4877,7 @@
                 <a:solidFill>
                   <a:srgbClr val="E4E4E7"/>
                 </a:solidFill>
-                <a:latin typeface="Calibri"/>
+                <a:latin typeface="Arial"/>
               </a:rPr>
               <a:t>🎯</a:t>
             </a:r>
@@ -4912,7 +4912,7 @@
                 <a:solidFill>
                   <a:srgbClr val="FFFFFF"/>
                 </a:solidFill>
-                <a:latin typeface="Calibri"/>
+                <a:latin typeface="Arial"/>
               </a:rPr>
               <a:t>Você aprendeu o fluxo completo!</a:t>
             </a:r>
@@ -4947,7 +4947,7 @@
                 <a:solidFill>
                   <a:srgbClr val="F9A026"/>
                 </a:solidFill>
-                <a:latin typeface="Consolas"/>
+                <a:latin typeface="Courier New"/>
               </a:rPr>
               <a:t>clone  →  branch  →  fix  →  commit  →  push  →  PR  →  merge</a:t>
             </a:r>
@@ -4982,7 +4982,7 @@
                 <a:solidFill>
                   <a:srgbClr val="E4E4E7"/>
                 </a:solidFill>
-                <a:latin typeface="Calibri"/>
+                <a:latin typeface="Arial"/>
               </a:rPr>
               <a:t>Perguntas?</a:t>
             </a:r>
@@ -5017,7 +5017,7 @@
                 <a:solidFill>
                   <a:srgbClr val="888899"/>
                 </a:solidFill>
-                <a:latin typeface="Consolas"/>
+                <a:latin typeface="Courier New"/>
               </a:rPr>
               <a:t>github.com/huyhian9-dotcom/git-demo-calculadora</a:t>
             </a:r>
@@ -5157,7 +5157,7 @@
                 <a:solidFill>
                   <a:srgbClr val="FFFFFF"/>
                 </a:solidFill>
-                <a:latin typeface="Calibri"/>
+                <a:latin typeface="Arial"/>
               </a:rPr>
               <a:t>O que é Versionamento?</a:t>
             </a:r>
@@ -5192,7 +5192,7 @@
                 <a:solidFill>
                   <a:srgbClr val="F9A026"/>
                 </a:solidFill>
-                <a:latin typeface="Calibri"/>
+                <a:latin typeface="Arial"/>
               </a:rPr>
               <a:t>Controle de histórico do código</a:t>
             </a:r>
@@ -5227,7 +5227,7 @@
                 <a:solidFill>
                   <a:srgbClr val="888899"/>
                 </a:solidFill>
-                <a:latin typeface="Calibri"/>
+                <a:latin typeface="Arial"/>
               </a:rPr>
               <a:t>Versionamento com Git  •  Slide 2/13</a:t>
             </a:r>
@@ -5266,7 +5266,7 @@
                 <a:solidFill>
                   <a:srgbClr val="E4E4E7"/>
                 </a:solidFill>
-                <a:latin typeface="Calibri"/>
+                <a:latin typeface="Arial"/>
               </a:rPr>
               <a:t>•  Registra TODA mudança feita no código ao longo do tempo</a:t>
             </a:r>
@@ -5282,7 +5282,7 @@
                 <a:solidFill>
                   <a:srgbClr val="E4E4E7"/>
                 </a:solidFill>
-                <a:latin typeface="Calibri"/>
+                <a:latin typeface="Arial"/>
               </a:rPr>
               <a:t>•  Permite voltar pra qualquer versão anterior (ctrl+z turbinado)</a:t>
             </a:r>
@@ -5298,7 +5298,7 @@
                 <a:solidFill>
                   <a:srgbClr val="E4E4E7"/>
                 </a:solidFill>
-                <a:latin typeface="Calibri"/>
+                <a:latin typeface="Arial"/>
               </a:rPr>
               <a:t>•  Vários devs trabalhando no mesmo projeto sem pisar no pé do outro</a:t>
             </a:r>
@@ -5314,7 +5314,7 @@
                 <a:solidFill>
                   <a:srgbClr val="E4E4E7"/>
                 </a:solidFill>
-                <a:latin typeface="Calibri"/>
+                <a:latin typeface="Arial"/>
               </a:rPr>
               <a:t>•  Mostra QUEM mudou O QUE e QUANDO</a:t>
             </a:r>
@@ -5330,7 +5330,7 @@
                 <a:solidFill>
                   <a:srgbClr val="E4E4E7"/>
                 </a:solidFill>
-                <a:latin typeface="Calibri"/>
+                <a:latin typeface="Arial"/>
               </a:rPr>
               <a:t>•  É a ferramenta mais importante do dia-a-dia do desenvolvedor</a:t>
             </a:r>
@@ -5470,7 +5470,7 @@
                 <a:solidFill>
                   <a:srgbClr val="FFFFFF"/>
                 </a:solidFill>
-                <a:latin typeface="Calibri"/>
+                <a:latin typeface="Arial"/>
               </a:rPr>
               <a:t>Por que Git?</a:t>
             </a:r>
@@ -5505,7 +5505,7 @@
                 <a:solidFill>
                   <a:srgbClr val="F9A026"/>
                 </a:solidFill>
-                <a:latin typeface="Calibri"/>
+                <a:latin typeface="Arial"/>
               </a:rPr>
               <a:t>O padrão da indústria</a:t>
             </a:r>
@@ -5540,7 +5540,7 @@
                 <a:solidFill>
                   <a:srgbClr val="888899"/>
                 </a:solidFill>
-                <a:latin typeface="Calibri"/>
+                <a:latin typeface="Arial"/>
               </a:rPr>
               <a:t>Versionamento com Git  •  Slide 3/13</a:t>
             </a:r>
@@ -5579,7 +5579,7 @@
                 <a:solidFill>
                   <a:srgbClr val="E4E4E7"/>
                 </a:solidFill>
-                <a:latin typeface="Calibri"/>
+                <a:latin typeface="Arial"/>
               </a:rPr>
               <a:t>•  ✅ Gratuito, open-source e funciona offline</a:t>
             </a:r>
@@ -5595,7 +5595,7 @@
                 <a:solidFill>
                   <a:srgbClr val="E4E4E7"/>
                 </a:solidFill>
-                <a:latin typeface="Calibri"/>
+                <a:latin typeface="Arial"/>
               </a:rPr>
               <a:t>•  ✅ Usado por 95%+ das empresas de tecnologia</a:t>
             </a:r>
@@ -5611,7 +5611,7 @@
                 <a:solidFill>
                   <a:srgbClr val="E4E4E7"/>
                 </a:solidFill>
-                <a:latin typeface="Calibri"/>
+                <a:latin typeface="Arial"/>
               </a:rPr>
               <a:t>•  ✅ Integra com GitHub, GitLab, Bitbucket…</a:t>
             </a:r>
@@ -5627,7 +5627,7 @@
                 <a:solidFill>
                   <a:srgbClr val="E4E4E7"/>
                 </a:solidFill>
-                <a:latin typeface="Calibri"/>
+                <a:latin typeface="Arial"/>
               </a:rPr>
               <a:t>•  ✅ Branches (ramificações) super baratas e rápidas</a:t>
             </a:r>
@@ -5643,7 +5643,7 @@
                 <a:solidFill>
                   <a:srgbClr val="E4E4E7"/>
                 </a:solidFill>
-                <a:latin typeface="Calibri"/>
+                <a:latin typeface="Arial"/>
               </a:rPr>
               <a:t>•  ✅ Histórico imutável — segurança e auditoria</a:t>
             </a:r>
@@ -5783,7 +5783,7 @@
                 <a:solidFill>
                   <a:srgbClr val="FFFFFF"/>
                 </a:solidFill>
-                <a:latin typeface="Calibri"/>
+                <a:latin typeface="Arial"/>
               </a:rPr>
               <a:t>Conceitos Fundamentais</a:t>
             </a:r>
@@ -5818,7 +5818,7 @@
                 <a:solidFill>
                   <a:srgbClr val="888899"/>
                 </a:solidFill>
-                <a:latin typeface="Calibri"/>
+                <a:latin typeface="Arial"/>
               </a:rPr>
               <a:t>Versionamento com Git  •  Slide 4/13</a:t>
             </a:r>
@@ -5857,7 +5857,7 @@
                 <a:solidFill>
                   <a:srgbClr val="E4E4E7"/>
                 </a:solidFill>
-                <a:latin typeface="Calibri"/>
+                <a:latin typeface="Arial"/>
               </a:rPr>
               <a:t>•  Repositório: pasta versionada pelo Git</a:t>
             </a:r>
@@ -5873,7 +5873,7 @@
                 <a:solidFill>
                   <a:srgbClr val="E4E4E7"/>
                 </a:solidFill>
-                <a:latin typeface="Calibri"/>
+                <a:latin typeface="Arial"/>
               </a:rPr>
               <a:t>•  Commit: uma 'foto' das mudanças, com mensagem</a:t>
             </a:r>
@@ -5889,7 +5889,7 @@
                 <a:solidFill>
                   <a:srgbClr val="E4E4E7"/>
                 </a:solidFill>
-                <a:latin typeface="Calibri"/>
+                <a:latin typeface="Arial"/>
               </a:rPr>
               <a:t>•  Branch: uma linha de desenvolvimento paralela</a:t>
             </a:r>
@@ -5905,7 +5905,7 @@
                 <a:solidFill>
                   <a:srgbClr val="E4E4E7"/>
                 </a:solidFill>
-                <a:latin typeface="Calibri"/>
+                <a:latin typeface="Arial"/>
               </a:rPr>
               <a:t>•  Merge: juntar uma branch com outra</a:t>
             </a:r>
@@ -5921,7 +5921,7 @@
                 <a:solidFill>
                   <a:srgbClr val="E4E4E7"/>
                 </a:solidFill>
-                <a:latin typeface="Calibri"/>
+                <a:latin typeface="Arial"/>
               </a:rPr>
               <a:t>•  Pull Request (PR): pedido de revisão antes do merge</a:t>
             </a:r>
@@ -5937,7 +5937,7 @@
                 <a:solidFill>
                   <a:srgbClr val="E4E4E7"/>
                 </a:solidFill>
-                <a:latin typeface="Calibri"/>
+                <a:latin typeface="Arial"/>
               </a:rPr>
               <a:t>•  Remote: cópia do repositório no servidor (GitHub)</a:t>
             </a:r>
@@ -6077,7 +6077,7 @@
                 <a:solidFill>
                   <a:srgbClr val="FFFFFF"/>
                 </a:solidFill>
-                <a:latin typeface="Calibri"/>
+                <a:latin typeface="Arial"/>
               </a:rPr>
               <a:t>Comandos Essenciais</a:t>
             </a:r>
@@ -6112,7 +6112,7 @@
                 <a:solidFill>
                   <a:srgbClr val="F9A026"/>
                 </a:solidFill>
-                <a:latin typeface="Calibri"/>
+                <a:latin typeface="Arial"/>
               </a:rPr>
               <a:t>O mínimo do mínimo</a:t>
             </a:r>
@@ -6147,7 +6147,7 @@
                 <a:solidFill>
                   <a:srgbClr val="888899"/>
                 </a:solidFill>
-                <a:latin typeface="Calibri"/>
+                <a:latin typeface="Arial"/>
               </a:rPr>
               <a:t>Versionamento com Git  •  Slide 5/13</a:t>
             </a:r>
@@ -6228,7 +6228,7 @@
                 <a:solidFill>
                   <a:srgbClr val="10D990"/>
                 </a:solidFill>
-                <a:latin typeface="Consolas"/>
+                <a:latin typeface="Courier New"/>
               </a:rPr>
               <a:t>git clone &lt;url&gt;              # baixa um repositório</a:t>
             </a:r>
@@ -6239,7 +6239,7 @@
                 <a:solidFill>
                   <a:srgbClr val="10D990"/>
                 </a:solidFill>
-                <a:latin typeface="Consolas"/>
+                <a:latin typeface="Courier New"/>
               </a:rPr>
               <a:t>git status                   # o que mudou?</a:t>
             </a:r>
@@ -6250,7 +6250,7 @@
                 <a:solidFill>
                   <a:srgbClr val="10D990"/>
                 </a:solidFill>
-                <a:latin typeface="Consolas"/>
+                <a:latin typeface="Courier New"/>
               </a:rPr>
               <a:t>git checkout -b nova-branch  # cria e entra na branch</a:t>
             </a:r>
@@ -6261,7 +6261,7 @@
                 <a:solidFill>
                   <a:srgbClr val="10D990"/>
                 </a:solidFill>
-                <a:latin typeface="Consolas"/>
+                <a:latin typeface="Courier New"/>
               </a:rPr>
               <a:t>git add arquivo.py           # prepara pro commit</a:t>
             </a:r>
@@ -6272,7 +6272,7 @@
                 <a:solidFill>
                   <a:srgbClr val="10D990"/>
                 </a:solidFill>
-                <a:latin typeface="Consolas"/>
+                <a:latin typeface="Courier New"/>
               </a:rPr>
               <a:t>git commit -m "msg"          # registra o commit</a:t>
             </a:r>
@@ -6283,7 +6283,7 @@
                 <a:solidFill>
                   <a:srgbClr val="10D990"/>
                 </a:solidFill>
-                <a:latin typeface="Consolas"/>
+                <a:latin typeface="Courier New"/>
               </a:rPr>
               <a:t>git push origin nova-branch  # envia pro GitHub</a:t>
             </a:r>
@@ -6294,7 +6294,7 @@
                 <a:solidFill>
                   <a:srgbClr val="10D990"/>
                 </a:solidFill>
-                <a:latin typeface="Consolas"/>
+                <a:latin typeface="Courier New"/>
               </a:rPr>
               <a:t>git pull                     # baixa atualizações</a:t>
             </a:r>
@@ -6305,7 +6305,7 @@
                 <a:solidFill>
                   <a:srgbClr val="10D990"/>
                 </a:solidFill>
-                <a:latin typeface="Consolas"/>
+                <a:latin typeface="Courier New"/>
               </a:rPr>
               <a:t>git log --oneline            # histórico resumido</a:t>
             </a:r>
@@ -6445,7 +6445,7 @@
                 <a:solidFill>
                   <a:srgbClr val="FFFFFF"/>
                 </a:solidFill>
-                <a:latin typeface="Calibri"/>
+                <a:latin typeface="Arial"/>
               </a:rPr>
               <a:t>🧪 Demo Prática</a:t>
             </a:r>
@@ -6480,7 +6480,7 @@
                 <a:solidFill>
                   <a:srgbClr val="F9A026"/>
                 </a:solidFill>
-                <a:latin typeface="Calibri"/>
+                <a:latin typeface="Arial"/>
               </a:rPr>
               <a:t>Calculadora React com um bug simples</a:t>
             </a:r>
@@ -6515,7 +6515,7 @@
                 <a:solidFill>
                   <a:srgbClr val="888899"/>
                 </a:solidFill>
-                <a:latin typeface="Calibri"/>
+                <a:latin typeface="Arial"/>
               </a:rPr>
               <a:t>Versionamento com Git  •  Slide 6/13</a:t>
             </a:r>
@@ -6550,7 +6550,7 @@
                 <a:solidFill>
                   <a:srgbClr val="E4E4E7"/>
                 </a:solidFill>
-                <a:latin typeface="Calibri"/>
+                <a:latin typeface="Arial"/>
               </a:rPr>
               <a:t>Quando a página carrega, o logo no topo aparece QUEBRADO.</a:t>
             </a:r>
@@ -6585,7 +6585,7 @@
                 <a:solidFill>
                   <a:srgbClr val="EF4444"/>
                 </a:solidFill>
-                <a:latin typeface="Calibri"/>
+                <a:latin typeface="Arial"/>
               </a:rPr>
               <a:t>…o arquivo que o HTML tenta carregar não existe (404).</a:t>
             </a:r>
@@ -6624,7 +6624,7 @@
                 <a:solidFill>
                   <a:srgbClr val="E4E4E7"/>
                 </a:solidFill>
-                <a:latin typeface="Calibri"/>
+                <a:latin typeface="Arial"/>
               </a:rPr>
               <a:t>•  Repositório: github.com/huyhian9-dotcom/git-demo-calculadora</a:t>
             </a:r>
@@ -6640,7 +6640,7 @@
                 <a:solidFill>
                   <a:srgbClr val="E4E4E7"/>
                 </a:solidFill>
-                <a:latin typeface="Calibri"/>
+                <a:latin typeface="Arial"/>
               </a:rPr>
               <a:t>•  Pré-requisitos: Node.js 18+ e Git instalados</a:t>
             </a:r>
@@ -6656,7 +6656,7 @@
                 <a:solidFill>
                   <a:srgbClr val="E4E4E7"/>
                 </a:solidFill>
-                <a:latin typeface="Calibri"/>
+                <a:latin typeface="Arial"/>
               </a:rPr>
               <a:t>•  Você vai investigar pelo DevTools (F12) → aba Network</a:t>
             </a:r>
@@ -6672,7 +6672,7 @@
                 <a:solidFill>
                   <a:srgbClr val="E4E4E7"/>
                 </a:solidFill>
-                <a:latin typeface="Calibri"/>
+                <a:latin typeface="Arial"/>
               </a:rPr>
               <a:t>•  Correção: um único caractere!  Sério.</a:t>
             </a:r>
@@ -6688,7 +6688,7 @@
                 <a:solidFill>
                   <a:srgbClr val="E4E4E7"/>
                 </a:solidFill>
-                <a:latin typeface="Calibri"/>
+                <a:latin typeface="Arial"/>
               </a:rPr>
               <a:t>•  Ao final, cada um vai ter enviado um Pull Request 🎯</a:t>
             </a:r>
@@ -6828,7 +6828,7 @@
                 <a:solidFill>
                   <a:srgbClr val="FFFFFF"/>
                 </a:solidFill>
-                <a:latin typeface="Calibri"/>
+                <a:latin typeface="Arial"/>
               </a:rPr>
               <a:t>Passo 1 — Clonar e rodar a aplicação</a:t>
             </a:r>
@@ -6863,7 +6863,7 @@
                 <a:solidFill>
                   <a:srgbClr val="888899"/>
                 </a:solidFill>
-                <a:latin typeface="Calibri"/>
+                <a:latin typeface="Arial"/>
               </a:rPr>
               <a:t>Versionamento com Git  •  Slide 7/13</a:t>
             </a:r>
@@ -6944,7 +6944,7 @@
                 <a:solidFill>
                   <a:srgbClr val="10D990"/>
                 </a:solidFill>
-                <a:latin typeface="Consolas"/>
+                <a:latin typeface="Courier New"/>
               </a:rPr>
               <a:t>git clone https://github.com/huyhian9-dotcom/git-demo-calculadora.git</a:t>
             </a:r>
@@ -6955,7 +6955,7 @@
                 <a:solidFill>
                   <a:srgbClr val="10D990"/>
                 </a:solidFill>
-                <a:latin typeface="Consolas"/>
+                <a:latin typeface="Courier New"/>
               </a:rPr>
               <a:t>cd git-demo-calculadora</a:t>
             </a:r>
@@ -6966,7 +6966,7 @@
                 <a:solidFill>
                   <a:srgbClr val="10D990"/>
                 </a:solidFill>
-                <a:latin typeface="Consolas"/>
+                <a:latin typeface="Courier New"/>
               </a:rPr>
               <a:t> </a:t>
             </a:r>
@@ -6977,7 +6977,7 @@
                 <a:solidFill>
                   <a:srgbClr val="10D990"/>
                 </a:solidFill>
-                <a:latin typeface="Consolas"/>
+                <a:latin typeface="Courier New"/>
               </a:rPr>
               <a:t>npm install      # instala React, Vite e afins</a:t>
             </a:r>
@@ -6988,7 +6988,7 @@
                 <a:solidFill>
                   <a:srgbClr val="10D990"/>
                 </a:solidFill>
-                <a:latin typeface="Consolas"/>
+                <a:latin typeface="Courier New"/>
               </a:rPr>
               <a:t>npm run dev      # abre em http://localhost:5173</a:t>
             </a:r>
@@ -7023,7 +7023,7 @@
                 <a:solidFill>
                   <a:srgbClr val="F9A026"/>
                 </a:solidFill>
-                <a:latin typeface="Calibri"/>
+                <a:latin typeface="Arial"/>
               </a:rPr>
               <a:t>A calculadora abre no navegador — o logo no topo aparece QUEBRADO.</a:t>
             </a:r>
@@ -7163,7 +7163,7 @@
                 <a:solidFill>
                   <a:srgbClr val="FFFFFF"/>
                 </a:solidFill>
-                <a:latin typeface="Calibri"/>
+                <a:latin typeface="Arial"/>
               </a:rPr>
               <a:t>Passo 2 — Abrir o DevTools</a:t>
             </a:r>
@@ -7198,7 +7198,7 @@
                 <a:solidFill>
                   <a:srgbClr val="F9A026"/>
                 </a:solidFill>
-                <a:latin typeface="Calibri"/>
+                <a:latin typeface="Arial"/>
               </a:rPr>
               <a:t>Como devs, investigamos bugs pelas ferramentas do navegador</a:t>
             </a:r>
@@ -7233,7 +7233,7 @@
                 <a:solidFill>
                   <a:srgbClr val="888899"/>
                 </a:solidFill>
-                <a:latin typeface="Calibri"/>
+                <a:latin typeface="Arial"/>
               </a:rPr>
               <a:t>Versionamento com Git  •  Slide 8/13</a:t>
             </a:r>
@@ -7272,7 +7272,7 @@
                 <a:solidFill>
                   <a:srgbClr val="E4E4E7"/>
                 </a:solidFill>
-                <a:latin typeface="Calibri"/>
+                <a:latin typeface="Arial"/>
               </a:rPr>
               <a:t>•  No navegador, pressione  F12  (ou Ctrl+Shift+I)</a:t>
             </a:r>
@@ -7288,7 +7288,7 @@
                 <a:solidFill>
                   <a:srgbClr val="E4E4E7"/>
                 </a:solidFill>
-                <a:latin typeface="Calibri"/>
+                <a:latin typeface="Arial"/>
               </a:rPr>
               <a:t>•  Vá até a aba  Network</a:t>
             </a:r>
@@ -7304,7 +7304,7 @@
                 <a:solidFill>
                   <a:srgbClr val="E4E4E7"/>
                 </a:solidFill>
-                <a:latin typeface="Calibri"/>
+                <a:latin typeface="Arial"/>
               </a:rPr>
               <a:t>•  Dê um refresh na página (F5)</a:t>
             </a:r>
@@ -7339,7 +7339,7 @@
                 <a:solidFill>
                   <a:srgbClr val="F9A026"/>
                 </a:solidFill>
-                <a:latin typeface="Calibri"/>
+                <a:latin typeface="Arial"/>
               </a:rPr>
               <a:t>Você verá uma requisição em VERMELHO:</a:t>
             </a:r>
@@ -7420,7 +7420,7 @@
                 <a:solidFill>
                   <a:srgbClr val="EF4444"/>
                 </a:solidFill>
-                <a:latin typeface="Consolas"/>
+                <a:latin typeface="Courier New"/>
               </a:rPr>
               <a:t>GET   /logoo.svg     404 Not Found  ❌</a:t>
             </a:r>
@@ -7455,7 +7455,7 @@
                 <a:solidFill>
                   <a:srgbClr val="E4E4E7"/>
                 </a:solidFill>
-                <a:latin typeface="Calibri"/>
+                <a:latin typeface="Arial"/>
               </a:rPr>
               <a:t>Percebeu o  "logoo"  com dois 'o'?  Esse é o bug.</a:t>
             </a:r>
@@ -7595,7 +7595,7 @@
                 <a:solidFill>
                   <a:srgbClr val="FFFFFF"/>
                 </a:solidFill>
-                <a:latin typeface="Calibri"/>
+                <a:latin typeface="Arial"/>
               </a:rPr>
               <a:t>Passo 3 — Criar uma branch de correção</a:t>
             </a:r>
@@ -7630,7 +7630,7 @@
                 <a:solidFill>
                   <a:srgbClr val="F9A026"/>
                 </a:solidFill>
-                <a:latin typeface="Calibri"/>
+                <a:latin typeface="Arial"/>
               </a:rPr>
               <a:t>Regra de ouro: nunca mexa direto na main</a:t>
             </a:r>
@@ -7665,7 +7665,7 @@
                 <a:solidFill>
                   <a:srgbClr val="888899"/>
                 </a:solidFill>
-                <a:latin typeface="Calibri"/>
+                <a:latin typeface="Arial"/>
               </a:rPr>
               <a:t>Versionamento com Git  •  Slide 9/13</a:t>
             </a:r>
@@ -7746,7 +7746,7 @@
                 <a:solidFill>
                   <a:srgbClr val="10D990"/>
                 </a:solidFill>
-                <a:latin typeface="Consolas"/>
+                <a:latin typeface="Courier New"/>
               </a:rPr>
               <a:t>git checkout -b fix/logo-path</a:t>
             </a:r>
@@ -7781,7 +7781,7 @@
                 <a:solidFill>
                   <a:srgbClr val="F9A026"/>
                 </a:solidFill>
-                <a:latin typeface="Calibri"/>
+                <a:latin typeface="Arial"/>
               </a:rPr>
               <a:t>O que aconteceu?</a:t>
             </a:r>
@@ -7820,7 +7820,7 @@
                 <a:solidFill>
                   <a:srgbClr val="E4E4E7"/>
                 </a:solidFill>
-                <a:latin typeface="Calibri"/>
+                <a:latin typeface="Arial"/>
               </a:rPr>
               <a:t>•  Criou uma nova branch chamada fix/logo-path</a:t>
             </a:r>
@@ -7836,7 +7836,7 @@
                 <a:solidFill>
                   <a:srgbClr val="E4E4E7"/>
                 </a:solidFill>
-                <a:latin typeface="Calibri"/>
+                <a:latin typeface="Arial"/>
               </a:rPr>
               <a:t>•  Trocou automaticamente pra ela (o -b faz isso)</a:t>
             </a:r>
@@ -7852,7 +7852,7 @@
                 <a:solidFill>
                   <a:srgbClr val="E4E4E7"/>
                 </a:solidFill>
-                <a:latin typeface="Calibri"/>
+                <a:latin typeface="Arial"/>
               </a:rPr>
               <a:t>•  Agora qualquer mudança fica isolada, sem afetar a main</a:t>
             </a:r>

</xml_diff>